<commit_message>
add sessie 2 and result of 1
</commit_message>
<xml_diff>
--- a/sessie_1_15-09/agenda sessie.pptx
+++ b/sessie_1_15-09/agenda sessie.pptx
@@ -126,7 +126,7 @@
   <pc:docChgLst>
     <pc:chgData name="Heemskerk, J.P.H. (Joris)" userId="be9757c8-c787-49b9-8775-e50e6ac111b0" providerId="ADAL" clId="{2FBCE334-D629-49FD-9448-DEBCBF5BBF77}"/>
     <pc:docChg chg="undo custSel addSld delSld modSld">
-      <pc:chgData name="Heemskerk, J.P.H. (Joris)" userId="be9757c8-c787-49b9-8775-e50e6ac111b0" providerId="ADAL" clId="{2FBCE334-D629-49FD-9448-DEBCBF5BBF77}" dt="2026-09-15T07:42:18.179" v="707" actId="20577"/>
+      <pc:chgData name="Heemskerk, J.P.H. (Joris)" userId="be9757c8-c787-49b9-8775-e50e6ac111b0" providerId="ADAL" clId="{2FBCE334-D629-49FD-9448-DEBCBF5BBF77}" dt="2026-09-15T08:14:14.410" v="709" actId="313"/>
       <pc:docMkLst>
         <pc:docMk/>
       </pc:docMkLst>
@@ -161,7 +161,7 @@
         </pc:spChg>
       </pc:sldChg>
       <pc:sldChg chg="modSp add mod">
-        <pc:chgData name="Heemskerk, J.P.H. (Joris)" userId="be9757c8-c787-49b9-8775-e50e6ac111b0" providerId="ADAL" clId="{2FBCE334-D629-49FD-9448-DEBCBF5BBF77}" dt="2026-09-15T07:42:18.179" v="707" actId="20577"/>
+        <pc:chgData name="Heemskerk, J.P.H. (Joris)" userId="be9757c8-c787-49b9-8775-e50e6ac111b0" providerId="ADAL" clId="{2FBCE334-D629-49FD-9448-DEBCBF5BBF77}" dt="2026-09-15T08:14:14.410" v="709" actId="313"/>
         <pc:sldMkLst>
           <pc:docMk/>
           <pc:sldMk cId="1537980087" sldId="258"/>
@@ -175,7 +175,7 @@
           </ac:spMkLst>
         </pc:spChg>
         <pc:spChg chg="mod">
-          <ac:chgData name="Heemskerk, J.P.H. (Joris)" userId="be9757c8-c787-49b9-8775-e50e6ac111b0" providerId="ADAL" clId="{2FBCE334-D629-49FD-9448-DEBCBF5BBF77}" dt="2026-09-15T07:42:18.179" v="707" actId="20577"/>
+          <ac:chgData name="Heemskerk, J.P.H. (Joris)" userId="be9757c8-c787-49b9-8775-e50e6ac111b0" providerId="ADAL" clId="{2FBCE334-D629-49FD-9448-DEBCBF5BBF77}" dt="2026-09-15T08:14:14.410" v="709" actId="313"/>
           <ac:spMkLst>
             <pc:docMk/>
             <pc:sldMk cId="1537980087" sldId="258"/>
@@ -3655,8 +3655,12 @@
           </a:p>
           <a:p>
             <a:r>
+              <a:rPr lang="nl-NL" dirty="0" err="1"/>
+              <a:t>Hubert’s</a:t>
+            </a:r>
+            <a:r>
               <a:rPr lang="nl-NL" dirty="0"/>
-              <a:t>Huberts notebook*</a:t>
+              <a:t> notebook*</a:t>
             </a:r>
           </a:p>
           <a:p>

</xml_diff>